<commit_message>
finale Version von Bonju
</commit_message>
<xml_diff>
--- a/Zwischenpraesentation_DC_Bonju.pptx
+++ b/Zwischenpraesentation_DC_Bonju.pptx
@@ -8,11 +8,12 @@
     <p:sldId id="256" r:id="rId2"/>
     <p:sldId id="263" r:id="rId3"/>
     <p:sldId id="257" r:id="rId4"/>
-    <p:sldId id="258" r:id="rId5"/>
-    <p:sldId id="259" r:id="rId6"/>
-    <p:sldId id="261" r:id="rId7"/>
-    <p:sldId id="262" r:id="rId8"/>
-    <p:sldId id="264" r:id="rId9"/>
+    <p:sldId id="265" r:id="rId5"/>
+    <p:sldId id="258" r:id="rId6"/>
+    <p:sldId id="259" r:id="rId7"/>
+    <p:sldId id="261" r:id="rId8"/>
+    <p:sldId id="262" r:id="rId9"/>
+    <p:sldId id="264" r:id="rId10"/>
   </p:sldIdLst>
   <p:sldSz cx="12192000" cy="6858000"/>
   <p:notesSz cx="6858000" cy="9144000"/>
@@ -248,7 +249,7 @@
           <a:p>
             <a:fld id="{D3EB3054-B75A-4BD7-8B3E-8DC0F614FAF3}" type="datetimeFigureOut">
               <a:rPr lang="de-DE" smtClean="0"/>
-              <a:t>08.06.2026</a:t>
+              <a:t>10.06.2026</a:t>
             </a:fld>
             <a:endParaRPr lang="de-DE"/>
           </a:p>
@@ -416,7 +417,7 @@
           <a:p>
             <a:fld id="{D3EB3054-B75A-4BD7-8B3E-8DC0F614FAF3}" type="datetimeFigureOut">
               <a:rPr lang="de-DE" smtClean="0"/>
-              <a:t>08.06.2026</a:t>
+              <a:t>10.06.2026</a:t>
             </a:fld>
             <a:endParaRPr lang="de-DE"/>
           </a:p>
@@ -594,7 +595,7 @@
           <a:p>
             <a:fld id="{D3EB3054-B75A-4BD7-8B3E-8DC0F614FAF3}" type="datetimeFigureOut">
               <a:rPr lang="de-DE" smtClean="0"/>
-              <a:t>08.06.2026</a:t>
+              <a:t>10.06.2026</a:t>
             </a:fld>
             <a:endParaRPr lang="de-DE"/>
           </a:p>
@@ -762,7 +763,7 @@
           <a:p>
             <a:fld id="{D3EB3054-B75A-4BD7-8B3E-8DC0F614FAF3}" type="datetimeFigureOut">
               <a:rPr lang="de-DE" smtClean="0"/>
-              <a:t>08.06.2026</a:t>
+              <a:t>10.06.2026</a:t>
             </a:fld>
             <a:endParaRPr lang="de-DE"/>
           </a:p>
@@ -1007,7 +1008,7 @@
           <a:p>
             <a:fld id="{D3EB3054-B75A-4BD7-8B3E-8DC0F614FAF3}" type="datetimeFigureOut">
               <a:rPr lang="de-DE" smtClean="0"/>
-              <a:t>08.06.2026</a:t>
+              <a:t>10.06.2026</a:t>
             </a:fld>
             <a:endParaRPr lang="de-DE"/>
           </a:p>
@@ -1236,7 +1237,7 @@
           <a:p>
             <a:fld id="{D3EB3054-B75A-4BD7-8B3E-8DC0F614FAF3}" type="datetimeFigureOut">
               <a:rPr lang="de-DE" smtClean="0"/>
-              <a:t>08.06.2026</a:t>
+              <a:t>10.06.2026</a:t>
             </a:fld>
             <a:endParaRPr lang="de-DE"/>
           </a:p>
@@ -1600,7 +1601,7 @@
           <a:p>
             <a:fld id="{D3EB3054-B75A-4BD7-8B3E-8DC0F614FAF3}" type="datetimeFigureOut">
               <a:rPr lang="de-DE" smtClean="0"/>
-              <a:t>08.06.2026</a:t>
+              <a:t>10.06.2026</a:t>
             </a:fld>
             <a:endParaRPr lang="de-DE"/>
           </a:p>
@@ -1717,7 +1718,7 @@
           <a:p>
             <a:fld id="{D3EB3054-B75A-4BD7-8B3E-8DC0F614FAF3}" type="datetimeFigureOut">
               <a:rPr lang="de-DE" smtClean="0"/>
-              <a:t>08.06.2026</a:t>
+              <a:t>10.06.2026</a:t>
             </a:fld>
             <a:endParaRPr lang="de-DE"/>
           </a:p>
@@ -1812,7 +1813,7 @@
           <a:p>
             <a:fld id="{D3EB3054-B75A-4BD7-8B3E-8DC0F614FAF3}" type="datetimeFigureOut">
               <a:rPr lang="de-DE" smtClean="0"/>
-              <a:t>08.06.2026</a:t>
+              <a:t>10.06.2026</a:t>
             </a:fld>
             <a:endParaRPr lang="de-DE"/>
           </a:p>
@@ -2087,7 +2088,7 @@
           <a:p>
             <a:fld id="{D3EB3054-B75A-4BD7-8B3E-8DC0F614FAF3}" type="datetimeFigureOut">
               <a:rPr lang="de-DE" smtClean="0"/>
-              <a:t>08.06.2026</a:t>
+              <a:t>10.06.2026</a:t>
             </a:fld>
             <a:endParaRPr lang="de-DE"/>
           </a:p>
@@ -2339,7 +2340,7 @@
           <a:p>
             <a:fld id="{D3EB3054-B75A-4BD7-8B3E-8DC0F614FAF3}" type="datetimeFigureOut">
               <a:rPr lang="de-DE" smtClean="0"/>
-              <a:t>08.06.2026</a:t>
+              <a:t>10.06.2026</a:t>
             </a:fld>
             <a:endParaRPr lang="de-DE"/>
           </a:p>
@@ -2550,7 +2551,7 @@
           <a:p>
             <a:fld id="{D3EB3054-B75A-4BD7-8B3E-8DC0F614FAF3}" type="datetimeFigureOut">
               <a:rPr lang="de-DE" smtClean="0"/>
-              <a:t>08.06.2026</a:t>
+              <a:t>10.06.2026</a:t>
             </a:fld>
             <a:endParaRPr lang="de-DE"/>
           </a:p>
@@ -3014,30 +3015,44 @@
           <a:lstStyle/>
           <a:p>
             <a:r>
-              <a:rPr lang="ko-KR" altLang="ko-KR" dirty="0" err="1"/>
+              <a:rPr lang="ko-KR" altLang="ko-KR" dirty="0">
+                <a:ea typeface="맑은 고딕"/>
+              </a:rPr>
+              <a:t>5217982 - </a:t>
+            </a:r>
+            <a:r>
+              <a:rPr lang="ko-KR" altLang="ko-KR" dirty="0" err="1">
+                <a:ea typeface="맑은 고딕"/>
+              </a:rPr>
               <a:t>Toni</a:t>
             </a:r>
             <a:r>
-              <a:rPr lang="ko-KR" altLang="ko-KR" dirty="0"/>
-              <a:t> </a:t>
-            </a:r>
-            <a:r>
-              <a:rPr lang="ko-KR" altLang="ko-KR" dirty="0" err="1"/>
+              <a:rPr lang="ko-KR" altLang="ko-KR" dirty="0">
+                <a:ea typeface="맑은 고딕"/>
+              </a:rPr>
+              <a:t> </a:t>
+            </a:r>
+            <a:r>
+              <a:rPr lang="ko-KR" altLang="ko-KR" dirty="0" err="1">
+                <a:ea typeface="맑은 고딕"/>
+              </a:rPr>
               <a:t>Jungbeck</a:t>
             </a:r>
-            <a:endParaRPr lang="de-DE" dirty="0"/>
-          </a:p>
-          <a:p>
-            <a:r>
-              <a:rPr lang="de-DE" dirty="0"/>
-              <a:t>8528087 </a:t>
-            </a:r>
-            <a:r>
-              <a:rPr lang="de-DE" dirty="0" err="1"/>
+            <a:endParaRPr lang="de-DE" altLang="ko-KR" dirty="0">
+              <a:ea typeface="맑은 고딕"/>
+            </a:endParaRPr>
+          </a:p>
+          <a:p>
+            <a:r>
+              <a:rPr lang="de-DE" altLang="ko-KR" dirty="0"/>
+              <a:t>8528087 - </a:t>
+            </a:r>
+            <a:r>
+              <a:rPr lang="de-DE" altLang="ko-KR" dirty="0" err="1"/>
               <a:t>Bonju</a:t>
             </a:r>
             <a:r>
-              <a:rPr lang="de-DE" dirty="0"/>
+              <a:rPr lang="de-DE" altLang="ko-KR" dirty="0"/>
               <a:t> Koo</a:t>
             </a:r>
           </a:p>
@@ -3421,7 +3436,7 @@
           <a:lstStyle/>
           <a:p>
             <a:r>
-              <a:rPr lang="de-DE"/>
+              <a:rPr lang="de-DE" dirty="0"/>
               <a:t>Vorgehen</a:t>
             </a:r>
           </a:p>
@@ -3446,30 +3461,447 @@
         <p:spPr/>
         <p:txBody>
           <a:bodyPr vert="horz" lIns="91440" tIns="45720" rIns="91440" bIns="45720" rtlCol="0" anchor="t">
-            <a:normAutofit/>
+            <a:normAutofit fontScale="85000" lnSpcReduction="20000"/>
           </a:bodyPr>
           <a:lstStyle/>
           <a:p>
-            <a:r>
-              <a:rPr lang="de-DE" dirty="0"/>
-              <a:t>Programmiersprache R</a:t>
-            </a:r>
-          </a:p>
-          <a:p>
-            <a:r>
-              <a:rPr lang="de-DE" dirty="0"/>
-              <a:t>Model Random Forest</a:t>
-            </a:r>
-          </a:p>
-          <a:p>
-            <a:r>
-              <a:rPr lang="de-DE" dirty="0" err="1"/>
+            <a:pPr marL="0" indent="0">
+              <a:buNone/>
+            </a:pPr>
+            <a:r>
+              <a:rPr lang="ko-KR" altLang="ko-KR" b="1" dirty="0" err="1"/>
+              <a:t>Datenaufbereitung</a:t>
+            </a:r>
+            <a:r>
+              <a:rPr lang="ko-KR" altLang="ko-KR" b="1" dirty="0"/>
+              <a:t> </a:t>
+            </a:r>
+            <a:r>
+              <a:rPr lang="ko-KR" altLang="ko-KR" b="1" dirty="0" err="1"/>
+              <a:t>in</a:t>
+            </a:r>
+            <a:r>
+              <a:rPr lang="ko-KR" altLang="ko-KR" b="1" dirty="0"/>
+              <a:t> </a:t>
+            </a:r>
+            <a:r>
+              <a:rPr lang="ko-KR" altLang="ko-KR" b="1" dirty="0" err="1"/>
+              <a:t>R</a:t>
+            </a:r>
+            <a:r>
+              <a:rPr lang="ko-KR" altLang="ko-KR" dirty="0"/>
+              <a:t> </a:t>
+            </a:r>
+            <a:endParaRPr lang="en-US" altLang="ko-KR" dirty="0"/>
+          </a:p>
+          <a:p>
+            <a:r>
+              <a:rPr lang="ko-KR" altLang="ko-KR" sz="2200" dirty="0" err="1"/>
+              <a:t>Archäologische</a:t>
+            </a:r>
+            <a:r>
+              <a:rPr lang="ko-KR" altLang="ko-KR" sz="2200" dirty="0"/>
+              <a:t> </a:t>
+            </a:r>
+            <a:r>
+              <a:rPr lang="ko-KR" altLang="ko-KR" sz="2200" dirty="0" err="1"/>
+              <a:t>Fundorte</a:t>
+            </a:r>
+            <a:r>
+              <a:rPr lang="ko-KR" altLang="ko-KR" sz="2200" dirty="0"/>
+              <a:t> </a:t>
+            </a:r>
+            <a:r>
+              <a:rPr lang="ko-KR" altLang="ko-KR" sz="2200" dirty="0" err="1"/>
+              <a:t>und</a:t>
+            </a:r>
+            <a:r>
+              <a:rPr lang="ko-KR" altLang="ko-KR" sz="2200" dirty="0"/>
+              <a:t> </a:t>
+            </a:r>
+            <a:r>
+              <a:rPr lang="ko-KR" altLang="ko-KR" sz="2200" dirty="0" err="1"/>
+              <a:t>Umweltvariablen</a:t>
+            </a:r>
+            <a:r>
+              <a:rPr lang="ko-KR" altLang="ko-KR" sz="2200" dirty="0"/>
+              <a:t> </a:t>
+            </a:r>
+            <a:r>
+              <a:rPr lang="ko-KR" altLang="ko-KR" sz="2200" dirty="0" err="1"/>
+              <a:t>zusammenführen</a:t>
+            </a:r>
+            <a:r>
+              <a:rPr lang="ko-KR" altLang="ko-KR" sz="2200" dirty="0"/>
+              <a:t> </a:t>
+            </a:r>
+          </a:p>
+          <a:p>
+            <a:r>
+              <a:rPr lang="ko-KR" altLang="ko-KR" sz="2200" dirty="0" err="1"/>
+              <a:t>Bereinigung</a:t>
+            </a:r>
+            <a:r>
+              <a:rPr lang="ko-KR" altLang="ko-KR" sz="2200" dirty="0"/>
+              <a:t> </a:t>
+            </a:r>
+            <a:r>
+              <a:rPr lang="ko-KR" altLang="ko-KR" sz="2200" dirty="0" err="1"/>
+              <a:t>und</a:t>
+            </a:r>
+            <a:r>
+              <a:rPr lang="ko-KR" altLang="ko-KR" sz="2200" dirty="0"/>
+              <a:t> </a:t>
+            </a:r>
+            <a:r>
+              <a:rPr lang="ko-KR" altLang="ko-KR" sz="2200" dirty="0" err="1"/>
+              <a:t>Standardisierung</a:t>
+            </a:r>
+            <a:r>
+              <a:rPr lang="ko-KR" altLang="ko-KR" sz="2200" dirty="0"/>
+              <a:t> </a:t>
+            </a:r>
+            <a:r>
+              <a:rPr lang="ko-KR" altLang="ko-KR" sz="2200" dirty="0" err="1"/>
+              <a:t>der</a:t>
+            </a:r>
+            <a:r>
+              <a:rPr lang="ko-KR" altLang="ko-KR" sz="2200" dirty="0"/>
+              <a:t> </a:t>
+            </a:r>
+            <a:r>
+              <a:rPr lang="ko-KR" altLang="ko-KR" sz="2200" dirty="0" err="1"/>
+              <a:t>Datensätze</a:t>
+            </a:r>
+            <a:r>
+              <a:rPr lang="ko-KR" altLang="ko-KR" sz="2200" dirty="0"/>
+              <a:t> </a:t>
+            </a:r>
+          </a:p>
+          <a:p>
+            <a:pPr marL="0" indent="0">
+              <a:buNone/>
+            </a:pPr>
+            <a:r>
+              <a:rPr lang="ko-KR" altLang="ko-KR" b="1" dirty="0" err="1"/>
+              <a:t>Generierung</a:t>
+            </a:r>
+            <a:r>
+              <a:rPr lang="ko-KR" altLang="ko-KR" b="1" dirty="0"/>
+              <a:t> </a:t>
+            </a:r>
+            <a:r>
+              <a:rPr lang="ko-KR" altLang="ko-KR" b="1" dirty="0" err="1"/>
+              <a:t>von</a:t>
+            </a:r>
+            <a:r>
+              <a:rPr lang="ko-KR" altLang="ko-KR" b="1" dirty="0"/>
+              <a:t> </a:t>
+            </a:r>
+            <a:r>
+              <a:rPr lang="ko-KR" altLang="ko-KR" b="1" dirty="0" err="1"/>
+              <a:t>Pseudo-Absences</a:t>
+            </a:r>
+            <a:r>
+              <a:rPr lang="ko-KR" altLang="ko-KR" dirty="0"/>
+              <a:t> </a:t>
+            </a:r>
+            <a:endParaRPr lang="en-US" altLang="ko-KR" dirty="0"/>
+          </a:p>
+          <a:p>
+            <a:r>
+              <a:rPr lang="ko-KR" altLang="ko-KR" sz="2100" dirty="0" err="1"/>
+              <a:t>Zufällige</a:t>
+            </a:r>
+            <a:r>
+              <a:rPr lang="ko-KR" altLang="ko-KR" sz="2100" dirty="0"/>
+              <a:t> </a:t>
+            </a:r>
+            <a:r>
+              <a:rPr lang="ko-KR" altLang="ko-KR" sz="2100" dirty="0" err="1"/>
+              <a:t>Nicht-Fundorte</a:t>
+            </a:r>
+            <a:r>
+              <a:rPr lang="ko-KR" altLang="ko-KR" sz="2100" dirty="0"/>
+              <a:t> </a:t>
+            </a:r>
+            <a:r>
+              <a:rPr lang="ko-KR" altLang="ko-KR" sz="2100" dirty="0" err="1"/>
+              <a:t>mit</a:t>
+            </a:r>
+            <a:r>
+              <a:rPr lang="ko-KR" altLang="ko-KR" sz="2100" dirty="0"/>
+              <a:t> </a:t>
+            </a:r>
+            <a:r>
+              <a:rPr lang="ko-KR" altLang="ko-KR" sz="2100" dirty="0" err="1"/>
+              <a:t>Mindestabstand</a:t>
+            </a:r>
+            <a:r>
+              <a:rPr lang="ko-KR" altLang="ko-KR" sz="2100" dirty="0"/>
+              <a:t> </a:t>
+            </a:r>
+            <a:r>
+              <a:rPr lang="ko-KR" altLang="ko-KR" sz="2100" dirty="0" err="1"/>
+              <a:t>zu</a:t>
+            </a:r>
+            <a:r>
+              <a:rPr lang="ko-KR" altLang="ko-KR" sz="2100" dirty="0"/>
+              <a:t> </a:t>
+            </a:r>
+            <a:r>
+              <a:rPr lang="ko-KR" altLang="ko-KR" sz="2100" dirty="0" err="1"/>
+              <a:t>bekannten</a:t>
+            </a:r>
+            <a:r>
+              <a:rPr lang="ko-KR" altLang="ko-KR" sz="2100" dirty="0"/>
+              <a:t> </a:t>
+            </a:r>
+            <a:r>
+              <a:rPr lang="ko-KR" altLang="ko-KR" sz="2100" dirty="0" err="1"/>
+              <a:t>Fundorten</a:t>
+            </a:r>
+            <a:r>
+              <a:rPr lang="ko-KR" altLang="ko-KR" sz="2100" dirty="0"/>
+              <a:t> </a:t>
+            </a:r>
+            <a:r>
+              <a:rPr lang="ko-KR" altLang="ko-KR" sz="2100" dirty="0" err="1"/>
+              <a:t>erzeugen</a:t>
+            </a:r>
+            <a:r>
+              <a:rPr lang="ko-KR" altLang="ko-KR" sz="2100" dirty="0"/>
+              <a:t> </a:t>
+            </a:r>
+          </a:p>
+          <a:p>
+            <a:pPr marL="0" indent="0">
+              <a:buNone/>
+            </a:pPr>
+            <a:r>
+              <a:rPr lang="ko-KR" altLang="ko-KR" b="1" dirty="0" err="1"/>
+              <a:t>Modellentwicklung</a:t>
+            </a:r>
+            <a:r>
+              <a:rPr lang="ko-KR" altLang="ko-KR" b="1" dirty="0"/>
+              <a:t> </a:t>
+            </a:r>
+            <a:r>
+              <a:rPr lang="ko-KR" altLang="ko-KR" b="1" dirty="0" err="1"/>
+              <a:t>in</a:t>
+            </a:r>
+            <a:r>
+              <a:rPr lang="ko-KR" altLang="ko-KR" b="1" dirty="0"/>
+              <a:t> </a:t>
+            </a:r>
+            <a:r>
+              <a:rPr lang="ko-KR" altLang="ko-KR" b="1" dirty="0" err="1"/>
+              <a:t>R</a:t>
+            </a:r>
+            <a:r>
+              <a:rPr lang="ko-KR" altLang="ko-KR" dirty="0"/>
+              <a:t> </a:t>
+            </a:r>
+            <a:endParaRPr lang="en-US" altLang="ko-KR" dirty="0"/>
+          </a:p>
+          <a:p>
+            <a:r>
+              <a:rPr lang="ko-KR" altLang="ko-KR" sz="1900" dirty="0" err="1"/>
+              <a:t>Random</a:t>
+            </a:r>
+            <a:r>
+              <a:rPr lang="ko-KR" altLang="ko-KR" sz="1900" dirty="0"/>
+              <a:t> </a:t>
+            </a:r>
+            <a:r>
+              <a:rPr lang="ko-KR" altLang="ko-KR" sz="1900" dirty="0" err="1"/>
+              <a:t>Forest</a:t>
+            </a:r>
+            <a:r>
+              <a:rPr lang="ko-KR" altLang="ko-KR" sz="1900" dirty="0"/>
+              <a:t> </a:t>
+            </a:r>
+            <a:r>
+              <a:rPr lang="ko-KR" altLang="ko-KR" sz="1900" dirty="0" err="1"/>
+              <a:t>zur</a:t>
+            </a:r>
+            <a:r>
+              <a:rPr lang="ko-KR" altLang="ko-KR" sz="1900" dirty="0"/>
+              <a:t> </a:t>
+            </a:r>
+            <a:r>
+              <a:rPr lang="ko-KR" altLang="ko-KR" sz="1900" dirty="0" err="1"/>
+              <a:t>Vorhersage</a:t>
+            </a:r>
+            <a:r>
+              <a:rPr lang="ko-KR" altLang="ko-KR" sz="1900" dirty="0"/>
+              <a:t> </a:t>
+            </a:r>
+            <a:r>
+              <a:rPr lang="ko-KR" altLang="ko-KR" sz="1900" dirty="0" err="1"/>
+              <a:t>von</a:t>
+            </a:r>
+            <a:r>
+              <a:rPr lang="ko-KR" altLang="ko-KR" sz="1900" dirty="0"/>
+              <a:t> </a:t>
+            </a:r>
+            <a:r>
+              <a:rPr lang="ko-KR" altLang="ko-KR" sz="1900" dirty="0" err="1"/>
+              <a:t>Fundortwahrscheinlichkeiten</a:t>
+            </a:r>
+            <a:r>
+              <a:rPr lang="ko-KR" altLang="ko-KR" sz="1900" dirty="0"/>
+              <a:t>  </a:t>
+            </a:r>
+          </a:p>
+          <a:p>
+            <a:pPr marL="0" indent="0">
+              <a:buNone/>
+            </a:pPr>
+            <a:r>
+              <a:rPr lang="ko-KR" altLang="ko-KR" b="1" dirty="0" err="1"/>
+              <a:t>Räumliche</a:t>
+            </a:r>
+            <a:r>
+              <a:rPr lang="ko-KR" altLang="ko-KR" b="1" dirty="0"/>
+              <a:t> </a:t>
+            </a:r>
+            <a:r>
+              <a:rPr lang="ko-KR" altLang="ko-KR" b="1" dirty="0" err="1"/>
+              <a:t>Vorhersage</a:t>
+            </a:r>
+            <a:r>
+              <a:rPr lang="ko-KR" altLang="ko-KR" dirty="0"/>
+              <a:t> </a:t>
+            </a:r>
+            <a:endParaRPr lang="en-US" altLang="ko-KR" dirty="0"/>
+          </a:p>
+          <a:p>
+            <a:r>
+              <a:rPr lang="ko-KR" altLang="ko-KR" sz="1800" dirty="0" err="1"/>
+              <a:t>Anwendung</a:t>
+            </a:r>
+            <a:r>
+              <a:rPr lang="ko-KR" altLang="ko-KR" sz="1800" dirty="0"/>
+              <a:t> </a:t>
+            </a:r>
+            <a:r>
+              <a:rPr lang="ko-KR" altLang="ko-KR" sz="1800" dirty="0" err="1"/>
+              <a:t>des</a:t>
+            </a:r>
+            <a:r>
+              <a:rPr lang="ko-KR" altLang="ko-KR" sz="1800" dirty="0"/>
+              <a:t> </a:t>
+            </a:r>
+            <a:r>
+              <a:rPr lang="ko-KR" altLang="ko-KR" sz="1800" dirty="0" err="1"/>
+              <a:t>Modells</a:t>
+            </a:r>
+            <a:r>
+              <a:rPr lang="ko-KR" altLang="ko-KR" sz="1800" dirty="0"/>
+              <a:t> </a:t>
+            </a:r>
+            <a:r>
+              <a:rPr lang="ko-KR" altLang="ko-KR" sz="1800" dirty="0" err="1"/>
+              <a:t>auf</a:t>
+            </a:r>
+            <a:r>
+              <a:rPr lang="ko-KR" altLang="ko-KR" sz="1800" dirty="0"/>
+              <a:t> </a:t>
+            </a:r>
+            <a:r>
+              <a:rPr lang="ko-KR" altLang="ko-KR" sz="1800" dirty="0" err="1"/>
+              <a:t>ein</a:t>
+            </a:r>
+            <a:r>
+              <a:rPr lang="ko-KR" altLang="ko-KR" sz="1800" dirty="0"/>
+              <a:t> </a:t>
+            </a:r>
+            <a:r>
+              <a:rPr lang="ko-KR" altLang="ko-KR" sz="1800" dirty="0" err="1"/>
+              <a:t>Raster</a:t>
+            </a:r>
+            <a:r>
+              <a:rPr lang="ko-KR" altLang="ko-KR" sz="1800" dirty="0"/>
+              <a:t> </a:t>
+            </a:r>
+            <a:endParaRPr lang="en-US" altLang="ko-KR" sz="1800" dirty="0"/>
+          </a:p>
+          <a:p>
+            <a:pPr marL="0" indent="0">
+              <a:buNone/>
+            </a:pPr>
+            <a:r>
+              <a:rPr lang="ko-KR" altLang="ko-KR" b="1" dirty="0" err="1"/>
+              <a:t>Visualisierung</a:t>
+            </a:r>
+            <a:r>
+              <a:rPr lang="ko-KR" altLang="ko-KR" b="1" dirty="0"/>
+              <a:t> &amp; </a:t>
+            </a:r>
+            <a:r>
+              <a:rPr lang="ko-KR" altLang="ko-KR" b="1" dirty="0" err="1"/>
+              <a:t>Evaluation</a:t>
+            </a:r>
+            <a:r>
+              <a:rPr lang="ko-KR" altLang="ko-KR" dirty="0"/>
+              <a:t> </a:t>
+            </a:r>
+            <a:endParaRPr lang="en-US" altLang="ko-KR" dirty="0"/>
+          </a:p>
+          <a:p>
+            <a:r>
+              <a:rPr lang="ko-KR" altLang="ko-KR" sz="1800" dirty="0" err="1"/>
               <a:t>Heatmap</a:t>
             </a:r>
             <a:r>
-              <a:rPr lang="de-DE" dirty="0"/>
-              <a:t> mit Wahrscheinlichkeiten</a:t>
-            </a:r>
+              <a:rPr lang="ko-KR" altLang="ko-KR" sz="1800" dirty="0"/>
+              <a:t> </a:t>
+            </a:r>
+            <a:r>
+              <a:rPr lang="ko-KR" altLang="ko-KR" sz="1800" dirty="0" err="1"/>
+              <a:t>potentieller</a:t>
+            </a:r>
+            <a:r>
+              <a:rPr lang="ko-KR" altLang="ko-KR" sz="1800" dirty="0"/>
+              <a:t> </a:t>
+            </a:r>
+            <a:r>
+              <a:rPr lang="ko-KR" altLang="ko-KR" sz="1800" dirty="0" err="1"/>
+              <a:t>Fundorte</a:t>
+            </a:r>
+            <a:r>
+              <a:rPr lang="ko-KR" altLang="ko-KR" sz="1800" dirty="0"/>
+              <a:t> </a:t>
+            </a:r>
+            <a:endParaRPr lang="en-US" altLang="ko-KR" sz="1800" dirty="0"/>
+          </a:p>
+          <a:p>
+            <a:r>
+              <a:rPr lang="ko-KR" altLang="ko-KR" sz="1800" dirty="0"/>
+              <a:t>ROC-AUC, </a:t>
+            </a:r>
+            <a:r>
+              <a:rPr lang="ko-KR" altLang="ko-KR" sz="1800" dirty="0" err="1"/>
+              <a:t>Sensitivity</a:t>
+            </a:r>
+            <a:r>
+              <a:rPr lang="ko-KR" altLang="ko-KR" sz="1800" dirty="0"/>
+              <a:t> </a:t>
+            </a:r>
+            <a:r>
+              <a:rPr lang="ko-KR" altLang="ko-KR" sz="1800" dirty="0" err="1"/>
+              <a:t>und</a:t>
+            </a:r>
+            <a:r>
+              <a:rPr lang="ko-KR" altLang="ko-KR" sz="1800" dirty="0"/>
+              <a:t> </a:t>
+            </a:r>
+            <a:r>
+              <a:rPr lang="ko-KR" altLang="ko-KR" sz="1800" dirty="0" err="1"/>
+              <a:t>Specificity</a:t>
+            </a:r>
+            <a:endParaRPr lang="ko-KR" altLang="ko-KR" sz="1800" dirty="0"/>
           </a:p>
         </p:txBody>
       </p:sp>
@@ -3535,6 +3967,127 @@
       </p:grpSpPr>
       <p:sp>
         <p:nvSpPr>
+          <p:cNvPr id="2" name="제목 1">
+            <a:extLst>
+              <a:ext uri="{FF2B5EF4-FFF2-40B4-BE49-F238E27FC236}">
+                <a16:creationId xmlns:a16="http://schemas.microsoft.com/office/drawing/2014/main" id="{C5A4B61F-9A12-1A5F-A7A1-14840762431B}"/>
+              </a:ext>
+            </a:extLst>
+          </p:cNvPr>
+          <p:cNvSpPr>
+            <a:spLocks noGrp="1"/>
+          </p:cNvSpPr>
+          <p:nvPr>
+            <p:ph type="title"/>
+          </p:nvPr>
+        </p:nvSpPr>
+        <p:spPr/>
+        <p:txBody>
+          <a:bodyPr/>
+          <a:lstStyle/>
+          <a:p>
+            <a:r>
+              <a:rPr lang="en-US" altLang="ko-KR" dirty="0" err="1"/>
+              <a:t>Zeitplan</a:t>
+            </a:r>
+            <a:endParaRPr lang="ko-KR" altLang="en-US" dirty="0"/>
+          </a:p>
+        </p:txBody>
+      </p:sp>
+      <p:pic>
+        <p:nvPicPr>
+          <p:cNvPr id="4" name="그림 3" descr="Datei:Goethe-Logo.svg">
+            <a:extLst>
+              <a:ext uri="{FF2B5EF4-FFF2-40B4-BE49-F238E27FC236}">
+                <a16:creationId xmlns:a16="http://schemas.microsoft.com/office/drawing/2014/main" id="{EA8B17CD-24FD-D93C-9C0C-EE1ECDA29A8E}"/>
+              </a:ext>
+            </a:extLst>
+          </p:cNvPr>
+          <p:cNvPicPr>
+            <a:picLocks noChangeAspect="1"/>
+          </p:cNvPicPr>
+          <p:nvPr/>
+        </p:nvPicPr>
+        <p:blipFill>
+          <a:blip r:embed="rId2"/>
+          <a:stretch>
+            <a:fillRect/>
+          </a:stretch>
+        </p:blipFill>
+        <p:spPr>
+          <a:xfrm>
+            <a:off x="9717833" y="112356"/>
+            <a:ext cx="2374641" cy="1296158"/>
+          </a:xfrm>
+          <a:prstGeom prst="rect">
+            <a:avLst/>
+          </a:prstGeom>
+        </p:spPr>
+      </p:pic>
+      <p:pic>
+        <p:nvPicPr>
+          <p:cNvPr id="5" name="table">
+            <a:extLst>
+              <a:ext uri="{FF2B5EF4-FFF2-40B4-BE49-F238E27FC236}">
+                <a16:creationId xmlns:a16="http://schemas.microsoft.com/office/drawing/2014/main" id="{FC388EEC-3ECB-0F95-9984-FE773728F8D0}"/>
+              </a:ext>
+            </a:extLst>
+          </p:cNvPr>
+          <p:cNvPicPr>
+            <a:picLocks noGrp="1" noChangeAspect="1"/>
+          </p:cNvPicPr>
+          <p:nvPr>
+            <p:ph idx="1"/>
+          </p:nvPr>
+        </p:nvPicPr>
+        <p:blipFill>
+          <a:blip r:embed="rId3"/>
+          <a:stretch>
+            <a:fillRect/>
+          </a:stretch>
+        </p:blipFill>
+        <p:spPr>
+          <a:xfrm>
+            <a:off x="1109728" y="1825625"/>
+            <a:ext cx="9972544" cy="4351338"/>
+          </a:xfrm>
+          <a:prstGeom prst="rect">
+            <a:avLst/>
+          </a:prstGeom>
+        </p:spPr>
+      </p:pic>
+    </p:spTree>
+    <p:extLst>
+      <p:ext uri="{BB962C8B-B14F-4D97-AF65-F5344CB8AC3E}">
+        <p14:creationId xmlns:p14="http://schemas.microsoft.com/office/powerpoint/2010/main" val="3675564922"/>
+      </p:ext>
+    </p:extLst>
+  </p:cSld>
+  <p:clrMapOvr>
+    <a:masterClrMapping/>
+  </p:clrMapOvr>
+</p:sld>
+</file>
+
+<file path=ppt/slides/slide5.xml><?xml version="1.0" encoding="utf-8"?>
+<p:sld xmlns:a="http://schemas.openxmlformats.org/drawingml/2006/main" xmlns:r="http://schemas.openxmlformats.org/officeDocument/2006/relationships" xmlns:p="http://schemas.openxmlformats.org/presentationml/2006/main">
+  <p:cSld>
+    <p:spTree>
+      <p:nvGrpSpPr>
+        <p:cNvPr id="1" name=""/>
+        <p:cNvGrpSpPr/>
+        <p:nvPr/>
+      </p:nvGrpSpPr>
+      <p:grpSpPr>
+        <a:xfrm>
+          <a:off x="0" y="0"/>
+          <a:ext cx="0" cy="0"/>
+          <a:chOff x="0" y="0"/>
+          <a:chExt cx="0" cy="0"/>
+        </a:xfrm>
+      </p:grpSpPr>
+      <p:sp>
+        <p:nvSpPr>
           <p:cNvPr id="2" name="Titel 1">
             <a:extLst>
               <a:ext uri="{FF2B5EF4-FFF2-40B4-BE49-F238E27FC236}">
@@ -3592,13 +4145,13 @@
               <a:t>DB-Verbindung</a:t>
             </a:r>
             <a:r>
-              <a:rPr lang="de-DE">
+              <a:rPr lang="de-DE" dirty="0">
                 <a:ea typeface="+mn-lt"/>
                 <a:cs typeface="+mn-lt"/>
               </a:rPr>
               <a:t> / Einlesen von umgewandelten CSV-Dateien</a:t>
             </a:r>
-            <a:endParaRPr lang="de-DE"/>
+            <a:endParaRPr lang="de-DE" dirty="0"/>
           </a:p>
           <a:p>
             <a:r>
@@ -3633,111 +4186,97 @@
           </a:p>
           <a:p>
             <a:r>
-              <a:rPr lang="de-DE" b="1">
-                <a:ea typeface="+mn-lt"/>
-                <a:cs typeface="+mn-lt"/>
-              </a:rPr>
-              <a:t>Pseudo-Absence-Generierung:</a:t>
-            </a:r>
-            <a:r>
-              <a:rPr lang="de-DE">
-                <a:ea typeface="+mn-lt"/>
-                <a:cs typeface="+mn-lt"/>
-              </a:rPr>
-              <a:t> zufällige Punkte in Bayern mit Mindestabstand (5 km) zu bekannten Fundorten </a:t>
-            </a:r>
-            <a:r>
-              <a:rPr lang="de-DE" err="1">
-                <a:ea typeface="+mn-lt"/>
-                <a:cs typeface="+mn-lt"/>
-              </a:rPr>
-              <a:t>generi</a:t>
-            </a:r>
-            <a:r>
-              <a:rPr lang="de-DE">
-                <a:ea typeface="+mn-lt"/>
-                <a:cs typeface="+mn-lt"/>
-              </a:rPr>
-              <a:t>eren</a:t>
-            </a:r>
-            <a:endParaRPr lang="de-DE"/>
-          </a:p>
-          <a:p>
-            <a:r>
-              <a:rPr lang="de-DE" b="1">
-                <a:ea typeface="+mn-lt"/>
-                <a:cs typeface="+mn-lt"/>
-              </a:rPr>
-              <a:t>Trainings-Datensatz</a:t>
-            </a:r>
-            <a:r>
-              <a:rPr lang="de-DE">
-                <a:ea typeface="+mn-lt"/>
-                <a:cs typeface="+mn-lt"/>
-              </a:rPr>
-              <a:t> zusammensetzen 1:2 Presence/Absence-Verhältnis</a:t>
-            </a:r>
-            <a:endParaRPr lang="de-DE"/>
-          </a:p>
-          <a:p>
-            <a:r>
               <a:rPr lang="de-DE" b="1" dirty="0">
                 <a:ea typeface="+mn-lt"/>
                 <a:cs typeface="+mn-lt"/>
               </a:rPr>
-              <a:t>Random Forest </a:t>
+              <a:t>Pseudo-Absence-Generierung:</a:t>
             </a:r>
             <a:r>
               <a:rPr lang="de-DE" dirty="0">
                 <a:ea typeface="+mn-lt"/>
                 <a:cs typeface="+mn-lt"/>
               </a:rPr>
-              <a:t>trainieren (via </a:t>
-            </a:r>
-            <a:r>
-              <a:rPr lang="de-DE" dirty="0" err="1">
-                <a:latin typeface="Consolas"/>
-              </a:rPr>
-              <a:t>ranger</a:t>
+              <a:t> zufällige Punkte in Bayern mit Mindestabstand (5 km) zu bekannten Fundorten generieren</a:t>
+            </a:r>
+            <a:endParaRPr lang="de-DE" dirty="0"/>
+          </a:p>
+          <a:p>
+            <a:r>
+              <a:rPr lang="de-DE" b="1" dirty="0">
+                <a:ea typeface="+mn-lt"/>
+                <a:cs typeface="+mn-lt"/>
+              </a:rPr>
+              <a:t>Trainings-Datensatz</a:t>
             </a:r>
             <a:r>
               <a:rPr lang="de-DE" dirty="0">
                 <a:ea typeface="+mn-lt"/>
                 <a:cs typeface="+mn-lt"/>
               </a:rPr>
-              <a:t> + </a:t>
-            </a:r>
-            <a:r>
-              <a:rPr lang="de-DE" dirty="0" err="1">
-                <a:latin typeface="Consolas"/>
-              </a:rPr>
-              <a:t>caret</a:t>
+              <a:t> zusammensetzen 1:2 Presence/Absence-Verhältnis</a:t>
+            </a:r>
+            <a:endParaRPr lang="de-DE" dirty="0"/>
+          </a:p>
+          <a:p>
+            <a:r>
+              <a:rPr lang="de-DE" b="1" dirty="0">
+                <a:ea typeface="+mn-lt"/>
+                <a:cs typeface="+mn-lt"/>
+              </a:rPr>
+              <a:t>Random Forest </a:t>
             </a:r>
             <a:r>
               <a:rPr lang="de-DE" dirty="0">
                 <a:ea typeface="+mn-lt"/>
                 <a:cs typeface="+mn-lt"/>
               </a:rPr>
-              <a:t>) mit 5-fold Cross-Validation, ROC als Metrik</a:t>
-            </a:r>
-            <a:endParaRPr lang="de-DE" dirty="0"/>
-          </a:p>
-          <a:p>
-            <a:r>
-              <a:rPr lang="de-DE" b="1">
+              <a:t>trainieren (via </a:t>
+            </a:r>
+            <a:r>
+              <a:rPr lang="de-DE" dirty="0" err="1">
+                <a:latin typeface="Consolas"/>
+              </a:rPr>
+              <a:t>ranger</a:t>
+            </a:r>
+            <a:r>
+              <a:rPr lang="de-DE" dirty="0">
                 <a:ea typeface="+mn-lt"/>
                 <a:cs typeface="+mn-lt"/>
               </a:rPr>
-              <a:t>Vorhersage-Raster</a:t>
-            </a:r>
-            <a:r>
-              <a:rPr lang="de-DE">
+              <a:t> + </a:t>
+            </a:r>
+            <a:r>
+              <a:rPr lang="de-DE" dirty="0" err="1">
+                <a:latin typeface="Consolas"/>
+              </a:rPr>
+              <a:t>caret</a:t>
+            </a:r>
+            <a:r>
+              <a:rPr lang="de-DE" dirty="0">
                 <a:ea typeface="+mn-lt"/>
                 <a:cs typeface="+mn-lt"/>
               </a:rPr>
+              <a:t>) mit 5-fold Cross-Validation, ROC als Metrik</a:t>
+            </a:r>
+            <a:endParaRPr lang="de-DE" dirty="0"/>
+          </a:p>
+          <a:p>
+            <a:r>
+              <a:rPr lang="de-DE" b="1" dirty="0">
+                <a:ea typeface="+mn-lt"/>
+                <a:cs typeface="+mn-lt"/>
+              </a:rPr>
+              <a:t>Vorhersage-Raster</a:t>
+            </a:r>
+            <a:r>
+              <a:rPr lang="de-DE" dirty="0">
+                <a:ea typeface="+mn-lt"/>
+                <a:cs typeface="+mn-lt"/>
+              </a:rPr>
               <a:t> erstellen; Gitterpunkte über ganz Bayern</a:t>
             </a:r>
-            <a:endParaRPr lang="de-DE"/>
+            <a:endParaRPr lang="de-DE" dirty="0"/>
           </a:p>
           <a:p>
             <a:r>
@@ -3779,7 +4318,7 @@
           </a:p>
           <a:p>
             <a:r>
-              <a:rPr lang="de-DE" b="1">
+              <a:rPr lang="de-DE" b="1" dirty="0">
                 <a:ea typeface="+mn-lt"/>
                 <a:cs typeface="+mn-lt"/>
               </a:rPr>
@@ -3794,7 +4333,7 @@
               <a:t> </a:t>
             </a:r>
             <a:r>
-              <a:rPr lang="de-DE">
+              <a:rPr lang="de-DE" dirty="0">
                 <a:latin typeface="Consolas"/>
                 <a:ea typeface="+mn-lt"/>
                 <a:cs typeface="+mn-lt"/>
@@ -3802,19 +4341,19 @@
               <a:t>viridis</a:t>
             </a:r>
             <a:r>
-              <a:rPr lang="de-DE">
+              <a:rPr lang="de-DE" dirty="0">
                 <a:latin typeface="Consolas"/>
               </a:rPr>
               <a:t>/magma</a:t>
             </a:r>
             <a:r>
-              <a:rPr lang="de-DE">
+              <a:rPr lang="de-DE" dirty="0">
                 <a:ea typeface="+mn-lt"/>
                 <a:cs typeface="+mn-lt"/>
               </a:rPr>
               <a:t>-Farbskala + bekannte Fundorte als gelbe Punkte</a:t>
             </a:r>
-            <a:endParaRPr lang="de-DE"/>
+            <a:endParaRPr lang="de-DE" dirty="0"/>
           </a:p>
           <a:p>
             <a:r>
@@ -3912,7 +4451,7 @@
 </p:sld>
 </file>
 
-<file path=ppt/slides/slide5.xml><?xml version="1.0" encoding="utf-8"?>
+<file path=ppt/slides/slide6.xml><?xml version="1.0" encoding="utf-8"?>
 <p:sld xmlns:a="http://schemas.openxmlformats.org/drawingml/2006/main" xmlns:r="http://schemas.openxmlformats.org/officeDocument/2006/relationships" xmlns:p="http://schemas.openxmlformats.org/presentationml/2006/main">
   <p:cSld>
     <p:spTree>
@@ -4458,7 +4997,7 @@
 </p:sld>
 </file>
 
-<file path=ppt/slides/slide6.xml><?xml version="1.0" encoding="utf-8"?>
+<file path=ppt/slides/slide7.xml><?xml version="1.0" encoding="utf-8"?>
 <p:sld xmlns:a="http://schemas.openxmlformats.org/drawingml/2006/main" xmlns:r="http://schemas.openxmlformats.org/officeDocument/2006/relationships" xmlns:p="http://schemas.openxmlformats.org/presentationml/2006/main">
   <p:cSld>
     <p:spTree>
@@ -4750,7 +5289,7 @@
 </p:sld>
 </file>
 
-<file path=ppt/slides/slide7.xml><?xml version="1.0" encoding="utf-8"?>
+<file path=ppt/slides/slide8.xml><?xml version="1.0" encoding="utf-8"?>
 <p:sld xmlns:a="http://schemas.openxmlformats.org/drawingml/2006/main" xmlns:r="http://schemas.openxmlformats.org/officeDocument/2006/relationships" xmlns:p="http://schemas.openxmlformats.org/presentationml/2006/main">
   <p:cSld>
     <p:spTree>
@@ -4959,7 +5498,7 @@
 </p:sld>
 </file>
 
-<file path=ppt/slides/slide8.xml><?xml version="1.0" encoding="utf-8"?>
+<file path=ppt/slides/slide9.xml><?xml version="1.0" encoding="utf-8"?>
 <p:sld xmlns:a="http://schemas.openxmlformats.org/drawingml/2006/main" xmlns:r="http://schemas.openxmlformats.org/officeDocument/2006/relationships" xmlns:p="http://schemas.openxmlformats.org/presentationml/2006/main">
   <p:cSld>
     <p:spTree>

</xml_diff>